<commit_message>
chore(demos): ⬆️ FY26Q4 content refresh
- update to SPFx v1.23
- run through all exercise steps in associated MSLearn module to validate good working order
- updated steps & fixed typos where necessary
- updated slides where necessary
- update code samples to reflect MSLearn HOL exercise refresh & updates
- any & all users/names/company names/pictures/IDs are not real people/tenants... all are from M365 demo tenants provided by Microsoft
</commit_message>
<xml_diff>
--- a/slides.pptx
+++ b/slides.pptx
@@ -318,7 +318,7 @@
           <a:p>
             <a:fld id="{F5D67128-0ED3-F84C-AB75-26956BD6F773}" type="datetimeFigureOut">
               <a:rPr lang="en-US" smtClean="0"/>
-              <a:t>12/27/22</a:t>
+              <a:t>5/27/26</a:t>
             </a:fld>
             <a:endParaRPr lang="en-US"/>
           </a:p>
@@ -495,7 +495,7 @@
           <a:p>
             <a:fld id="{9E65F564-29A8-0243-B41B-CCCF740F82F1}" type="datetimeFigureOut">
               <a:rPr lang="en-US" smtClean="0"/>
-              <a:t>12/27/22</a:t>
+              <a:t>5/27/26</a:t>
             </a:fld>
             <a:endParaRPr lang="en-US"/>
           </a:p>
@@ -14354,7 +14354,7 @@
           <a:p>
             <a:r>
               <a:rPr lang="en-US" dirty="0"/>
-              <a:t>Basic Card</a:t>
+              <a:t>Generic Card</a:t>
             </a:r>
           </a:p>
         </p:txBody>
@@ -14600,7 +14600,7 @@
           <a:p>
             <a:r>
               <a:rPr lang="en-US" dirty="0"/>
-              <a:t>Image Card</a:t>
+              <a:t>Search Card</a:t>
             </a:r>
           </a:p>
         </p:txBody>
@@ -14622,7 +14622,7 @@
         <p:spPr>
           <a:xfrm>
             <a:off x="4022771" y="2514600"/>
-            <a:ext cx="2634933" cy="3535305"/>
+            <a:ext cx="3271778" cy="3535305"/>
           </a:xfrm>
           <a:prstGeom prst="rect">
             <a:avLst/>
@@ -14813,7 +14813,7 @@
             </a:pPr>
             <a:r>
               <a:rPr lang="en-US" sz="2000" dirty="0"/>
-              <a:t>Primary text</a:t>
+              <a:t>Label</a:t>
             </a:r>
           </a:p>
           <a:p>
@@ -14823,7 +14823,7 @@
             </a:pPr>
             <a:r>
               <a:rPr lang="en-US" sz="2000" dirty="0"/>
-              <a:t>Image URL</a:t>
+              <a:t>Search placeholder</a:t>
             </a:r>
           </a:p>
         </p:txBody>
@@ -14844,8 +14844,8 @@
         </p:nvSpPr>
         <p:spPr>
           <a:xfrm>
-            <a:off x="8016602" y="1690688"/>
-            <a:ext cx="3074714" cy="496772"/>
+            <a:off x="8016601" y="1690688"/>
+            <a:ext cx="3569147" cy="496772"/>
           </a:xfrm>
           <a:prstGeom prst="rect">
             <a:avLst/>
@@ -15022,7 +15022,7 @@
           <a:p>
             <a:r>
               <a:rPr lang="en-US" dirty="0"/>
-              <a:t>Primary Text Card</a:t>
+              <a:t>Data Visualization Card</a:t>
             </a:r>
           </a:p>
         </p:txBody>
@@ -15235,7 +15235,7 @@
             </a:pPr>
             <a:r>
               <a:rPr lang="en-US" sz="2000" dirty="0"/>
-              <a:t>Primary text</a:t>
+              <a:t>Visualization type</a:t>
             </a:r>
           </a:p>
           <a:p>
@@ -15245,7 +15245,7 @@
             </a:pPr>
             <a:r>
               <a:rPr lang="en-US" sz="2000" dirty="0"/>
-              <a:t>Description</a:t>
+              <a:t>Data series</a:t>
             </a:r>
           </a:p>
         </p:txBody>
@@ -15282,10 +15282,10 @@
       </p:pic>
       <p:pic>
         <p:nvPicPr>
-          <p:cNvPr id="26" name="Picture 25" descr="Chart&#10;&#10;Description automatically generated">
-            <a:extLst>
-              <a:ext uri="{FF2B5EF4-FFF2-40B4-BE49-F238E27FC236}">
-                <a16:creationId xmlns:a16="http://schemas.microsoft.com/office/drawing/2014/main" id="{52575228-CA9D-154A-1B6C-40501420D588}"/>
+          <p:cNvPr id="2" name="Picture 1" descr="Default People Search card">
+            <a:extLst>
+              <a:ext uri="{FF2B5EF4-FFF2-40B4-BE49-F238E27FC236}">
+                <a16:creationId xmlns:a16="http://schemas.microsoft.com/office/drawing/2014/main" id="{509BE99A-88CB-80B4-0750-DB011913B474}"/>
               </a:ext>
             </a:extLst>
           </p:cNvPr>
@@ -15302,20 +15302,25 @@
         </p:blipFill>
         <p:spPr>
           <a:xfrm>
-            <a:off x="3375202" y="3828757"/>
-            <a:ext cx="3916733" cy="2264361"/>
+            <a:off x="3234939" y="3830967"/>
+            <a:ext cx="4102214" cy="2224746"/>
           </a:xfrm>
           <a:prstGeom prst="rect">
             <a:avLst/>
           </a:prstGeom>
+          <a:ln>
+            <a:solidFill>
+              <a:schemeClr val="tx1"/>
+            </a:solidFill>
+          </a:ln>
         </p:spPr>
       </p:pic>
       <p:pic>
         <p:nvPicPr>
-          <p:cNvPr id="28" name="Picture 27" descr="Graphical user interface, text, application&#10;&#10;Description automatically generated">
-            <a:extLst>
-              <a:ext uri="{FF2B5EF4-FFF2-40B4-BE49-F238E27FC236}">
-                <a16:creationId xmlns:a16="http://schemas.microsoft.com/office/drawing/2014/main" id="{50BCA958-52AB-8943-46E7-CAA532DA2A51}"/>
+          <p:cNvPr id="4" name="Picture 3" descr="Default Data Visualization card">
+            <a:extLst>
+              <a:ext uri="{FF2B5EF4-FFF2-40B4-BE49-F238E27FC236}">
+                <a16:creationId xmlns:a16="http://schemas.microsoft.com/office/drawing/2014/main" id="{452E67B7-EC70-EE1C-9665-307DFB38AEDB}"/>
               </a:ext>
             </a:extLst>
           </p:cNvPr>
@@ -15332,12 +15337,17 @@
         </p:blipFill>
         <p:spPr>
           <a:xfrm>
-            <a:off x="7521164" y="3828757"/>
-            <a:ext cx="3884635" cy="2264360"/>
+            <a:off x="7607300" y="3830967"/>
+            <a:ext cx="4231690" cy="2227205"/>
           </a:xfrm>
           <a:prstGeom prst="rect">
             <a:avLst/>
           </a:prstGeom>
+          <a:ln>
+            <a:solidFill>
+              <a:schemeClr val="tx1"/>
+            </a:solidFill>
+          </a:ln>
         </p:spPr>
       </p:pic>
     </p:spTree>
@@ -16585,6 +16595,14 @@
 </file>
 
 <file path=customXml/item1.xml><?xml version="1.0" encoding="utf-8"?>
+<p:properties xmlns:p="http://schemas.microsoft.com/office/2006/metadata/properties" xmlns:xsi="http://www.w3.org/2001/XMLSchema-instance" xmlns:pc="http://schemas.microsoft.com/office/infopath/2007/PartnerControls">
+  <documentManagement>
+    <MediaServiceKeyPoints xmlns="61b79488-63fd-46f4-b1bf-09cb63d2085e" xsi:nil="true"/>
+  </documentManagement>
+</p:properties>
+</file>
+
+<file path=customXml/item2.xml><?xml version="1.0" encoding="utf-8"?>
 <ct:contentTypeSchema xmlns:ct="http://schemas.microsoft.com/office/2006/metadata/contentType" xmlns:ma="http://schemas.microsoft.com/office/2006/metadata/properties/metaAttributes" ct:_="" ma:_="" ma:contentTypeName="Document" ma:contentTypeID="0x010100F09820594E7B0041BAC4DECBBC892FF9" ma:contentTypeVersion="8" ma:contentTypeDescription="Create a new document." ma:contentTypeScope="" ma:versionID="a4814d1cc1d58eee3ea03778ca413c81">
   <xsd:schema xmlns:xsd="http://www.w3.org/2001/XMLSchema" xmlns:xs="http://www.w3.org/2001/XMLSchema" xmlns:p="http://schemas.microsoft.com/office/2006/metadata/properties" xmlns:ns2="61b79488-63fd-46f4-b1bf-09cb63d2085e" targetNamespace="http://schemas.microsoft.com/office/2006/metadata/properties" ma:root="true" ma:fieldsID="40fb5444c5ccb72d5b900b723022c04a" ns2:_="">
     <xsd:import namespace="61b79488-63fd-46f4-b1bf-09cb63d2085e"/>
@@ -16756,7 +16774,7 @@
 </ct:contentTypeSchema>
 </file>
 
-<file path=customXml/item2.xml><?xml version="1.0" encoding="utf-8"?>
+<file path=customXml/item3.xml><?xml version="1.0" encoding="utf-8"?>
 <?mso-contentType ?>
 <FormTemplates xmlns="http://schemas.microsoft.com/sharepoint/v3/contenttype/forms">
   <Display>DocumentLibraryForm</Display>
@@ -16765,15 +16783,23 @@
 </FormTemplates>
 </file>
 
-<file path=customXml/item3.xml><?xml version="1.0" encoding="utf-8"?>
-<p:properties xmlns:p="http://schemas.microsoft.com/office/2006/metadata/properties" xmlns:xsi="http://www.w3.org/2001/XMLSchema-instance" xmlns:pc="http://schemas.microsoft.com/office/infopath/2007/PartnerControls">
-  <documentManagement>
-    <MediaServiceKeyPoints xmlns="61b79488-63fd-46f4-b1bf-09cb63d2085e" xsi:nil="true"/>
-  </documentManagement>
-</p:properties>
+<file path=customXml/itemProps1.xml><?xml version="1.0" encoding="utf-8"?>
+<ds:datastoreItem xmlns:ds="http://schemas.openxmlformats.org/officeDocument/2006/customXml" ds:itemID="{56E9BD92-A245-451A-82D6-41724A6593BA}">
+  <ds:schemaRefs>
+    <ds:schemaRef ds:uri="http://purl.org/dc/elements/1.1/"/>
+    <ds:schemaRef ds:uri="http://schemas.microsoft.com/office/2006/documentManagement/types"/>
+    <ds:schemaRef ds:uri="http://purl.org/dc/dcmitype/"/>
+    <ds:schemaRef ds:uri="http://schemas.microsoft.com/office/infopath/2007/PartnerControls"/>
+    <ds:schemaRef ds:uri="http://schemas.openxmlformats.org/package/2006/metadata/core-properties"/>
+    <ds:schemaRef ds:uri="http://purl.org/dc/terms/"/>
+    <ds:schemaRef ds:uri="http://schemas.microsoft.com/office/2006/metadata/properties"/>
+    <ds:schemaRef ds:uri="http://www.w3.org/XML/1998/namespace"/>
+    <ds:schemaRef ds:uri="61b79488-63fd-46f4-b1bf-09cb63d2085e"/>
+  </ds:schemaRefs>
+</ds:datastoreItem>
 </file>
 
-<file path=customXml/itemProps1.xml><?xml version="1.0" encoding="utf-8"?>
+<file path=customXml/itemProps2.xml><?xml version="1.0" encoding="utf-8"?>
 <ds:datastoreItem xmlns:ds="http://schemas.openxmlformats.org/officeDocument/2006/customXml" ds:itemID="{535C360C-FC5A-43F7-BF1D-FA69DEF501D3}">
   <ds:schemaRefs>
     <ds:schemaRef ds:uri="http://schemas.microsoft.com/office/2006/metadata/contentType"/>
@@ -16791,26 +16817,10 @@
 </ds:datastoreItem>
 </file>
 
-<file path=customXml/itemProps2.xml><?xml version="1.0" encoding="utf-8"?>
+<file path=customXml/itemProps3.xml><?xml version="1.0" encoding="utf-8"?>
 <ds:datastoreItem xmlns:ds="http://schemas.openxmlformats.org/officeDocument/2006/customXml" ds:itemID="{4875BE8C-CB08-400E-A21F-2497FF16C77B}">
   <ds:schemaRefs>
     <ds:schemaRef ds:uri="http://schemas.microsoft.com/sharepoint/v3/contenttype/forms"/>
-  </ds:schemaRefs>
-</ds:datastoreItem>
-</file>
-
-<file path=customXml/itemProps3.xml><?xml version="1.0" encoding="utf-8"?>
-<ds:datastoreItem xmlns:ds="http://schemas.openxmlformats.org/officeDocument/2006/customXml" ds:itemID="{56E9BD92-A245-451A-82D6-41724A6593BA}">
-  <ds:schemaRefs>
-    <ds:schemaRef ds:uri="http://purl.org/dc/elements/1.1/"/>
-    <ds:schemaRef ds:uri="http://schemas.microsoft.com/office/2006/documentManagement/types"/>
-    <ds:schemaRef ds:uri="http://purl.org/dc/dcmitype/"/>
-    <ds:schemaRef ds:uri="http://schemas.microsoft.com/office/infopath/2007/PartnerControls"/>
-    <ds:schemaRef ds:uri="http://schemas.openxmlformats.org/package/2006/metadata/core-properties"/>
-    <ds:schemaRef ds:uri="http://purl.org/dc/terms/"/>
-    <ds:schemaRef ds:uri="http://schemas.microsoft.com/office/2006/metadata/properties"/>
-    <ds:schemaRef ds:uri="http://www.w3.org/XML/1998/namespace"/>
-    <ds:schemaRef ds:uri="61b79488-63fd-46f4-b1bf-09cb63d2085e"/>
   </ds:schemaRefs>
 </ds:datastoreItem>
 </file>

</xml_diff>